<commit_message>
docs: actualizar la presentacion final del proyecto y retirar la version en PDF que quedo desactualizada
</commit_message>
<xml_diff>
--- a/Documents/DOC-001_8_Presentación final.pptx
+++ b/Documents/DOC-001_8_Presentación final.pptx
@@ -15939,172 +15939,22 @@
               <a:gd name="adj" fmla="val 4082"/>
             </a:avLst>
           </a:prstGeom>
-          <a:solidFill>
-            <a:srgbClr val="111827"/>
-          </a:solidFill>
+          <a:blipFill dpi="0" rotWithShape="1">
+            <a:blip r:embed="rId3">
+              <a:extLst>
+                <a:ext uri="{28A0092B-C50C-407E-A947-70E740481C1C}">
+                  <a14:useLocalDpi xmlns:a14="http://schemas.microsoft.com/office/drawing/2010/main" val="0"/>
+                </a:ext>
+              </a:extLst>
+            </a:blip>
+            <a:srcRect/>
+            <a:stretch>
+              <a:fillRect/>
+            </a:stretch>
+          </a:blipFill>
           <a:ln w="12700">
             <a:solidFill>
               <a:srgbClr val="111827"/>
-            </a:solidFill>
-            <a:prstDash val="solid"/>
-          </a:ln>
-        </p:spPr>
-        <p:txBody>
-          <a:bodyPr/>
-          <a:lstStyle/>
-          <a:p>
-            <a:endParaRPr lang="es-NI"/>
-          </a:p>
-        </p:txBody>
-      </p:sp>
-      <p:sp>
-        <p:nvSpPr>
-          <p:cNvPr id="14" name="Shape 12"/>
-          <p:cNvSpPr/>
-          <p:nvPr/>
-        </p:nvSpPr>
-        <p:spPr>
-          <a:xfrm>
-            <a:off x="6968185" y="2089404"/>
-            <a:ext cx="1837030" cy="3044952"/>
-          </a:xfrm>
-          <a:prstGeom prst="rect">
-            <a:avLst/>
-          </a:prstGeom>
-          <a:solidFill>
-            <a:srgbClr val="FFFFFF"/>
-          </a:solidFill>
-          <a:ln w="9525">
-            <a:solidFill>
-              <a:srgbClr val="D7DCE4"/>
-            </a:solidFill>
-            <a:prstDash val="solid"/>
-          </a:ln>
-        </p:spPr>
-        <p:txBody>
-          <a:bodyPr/>
-          <a:lstStyle/>
-          <a:p>
-            <a:endParaRPr lang="es-NI"/>
-          </a:p>
-        </p:txBody>
-      </p:sp>
-      <p:sp>
-        <p:nvSpPr>
-          <p:cNvPr id="15" name="Shape 13"/>
-          <p:cNvSpPr/>
-          <p:nvPr/>
-        </p:nvSpPr>
-        <p:spPr>
-          <a:xfrm>
-            <a:off x="7057796" y="2336292"/>
-            <a:ext cx="1657807" cy="144018"/>
-          </a:xfrm>
-          <a:prstGeom prst="rect">
-            <a:avLst/>
-          </a:prstGeom>
-          <a:solidFill>
-            <a:srgbClr val="69B6E6"/>
-          </a:solidFill>
-          <a:ln w="12700">
-            <a:solidFill>
-              <a:srgbClr val="FFFFFF"/>
-            </a:solidFill>
-            <a:prstDash val="solid"/>
-          </a:ln>
-        </p:spPr>
-        <p:txBody>
-          <a:bodyPr/>
-          <a:lstStyle/>
-          <a:p>
-            <a:endParaRPr lang="es-NI"/>
-          </a:p>
-        </p:txBody>
-      </p:sp>
-      <p:sp>
-        <p:nvSpPr>
-          <p:cNvPr id="16" name="Shape 14"/>
-          <p:cNvSpPr/>
-          <p:nvPr/>
-        </p:nvSpPr>
-        <p:spPr>
-          <a:xfrm>
-            <a:off x="7057796" y="2974086"/>
-            <a:ext cx="1366571" cy="144018"/>
-          </a:xfrm>
-          <a:prstGeom prst="rect">
-            <a:avLst/>
-          </a:prstGeom>
-          <a:solidFill>
-            <a:srgbClr val="DCE3EC"/>
-          </a:solidFill>
-          <a:ln w="12700">
-            <a:solidFill>
-              <a:srgbClr val="FFFFFF"/>
-            </a:solidFill>
-            <a:prstDash val="solid"/>
-          </a:ln>
-        </p:spPr>
-        <p:txBody>
-          <a:bodyPr/>
-          <a:lstStyle/>
-          <a:p>
-            <a:endParaRPr lang="es-NI"/>
-          </a:p>
-        </p:txBody>
-      </p:sp>
-      <p:sp>
-        <p:nvSpPr>
-          <p:cNvPr id="17" name="Shape 15"/>
-          <p:cNvSpPr/>
-          <p:nvPr/>
-        </p:nvSpPr>
-        <p:spPr>
-          <a:xfrm>
-            <a:off x="7057796" y="3611880"/>
-            <a:ext cx="1075334" cy="144018"/>
-          </a:xfrm>
-          <a:prstGeom prst="rect">
-            <a:avLst/>
-          </a:prstGeom>
-          <a:solidFill>
-            <a:srgbClr val="DCE3EC"/>
-          </a:solidFill>
-          <a:ln w="12700">
-            <a:solidFill>
-              <a:srgbClr val="FFFFFF"/>
-            </a:solidFill>
-            <a:prstDash val="solid"/>
-          </a:ln>
-        </p:spPr>
-        <p:txBody>
-          <a:bodyPr/>
-          <a:lstStyle/>
-          <a:p>
-            <a:endParaRPr lang="es-NI"/>
-          </a:p>
-        </p:txBody>
-      </p:sp>
-      <p:sp>
-        <p:nvSpPr>
-          <p:cNvPr id="18" name="Shape 16"/>
-          <p:cNvSpPr/>
-          <p:nvPr/>
-        </p:nvSpPr>
-        <p:spPr>
-          <a:xfrm>
-            <a:off x="7057796" y="4352544"/>
-            <a:ext cx="370332" cy="370332"/>
-          </a:xfrm>
-          <a:prstGeom prst="ellipse">
-            <a:avLst/>
-          </a:prstGeom>
-          <a:solidFill>
-            <a:srgbClr val="F3961C"/>
-          </a:solidFill>
-          <a:ln w="12700">
-            <a:solidFill>
-              <a:srgbClr val="FFFFFF"/>
             </a:solidFill>
             <a:prstDash val="solid"/>
           </a:ln>
@@ -16172,172 +16022,22 @@
               <a:gd name="adj" fmla="val 4082"/>
             </a:avLst>
           </a:prstGeom>
-          <a:solidFill>
-            <a:srgbClr val="111827"/>
-          </a:solidFill>
+          <a:blipFill dpi="0" rotWithShape="1">
+            <a:blip r:embed="rId4">
+              <a:extLst>
+                <a:ext uri="{28A0092B-C50C-407E-A947-70E740481C1C}">
+                  <a14:useLocalDpi xmlns:a14="http://schemas.microsoft.com/office/drawing/2010/main" val="0"/>
+                </a:ext>
+              </a:extLst>
+            </a:blip>
+            <a:srcRect/>
+            <a:stretch>
+              <a:fillRect/>
+            </a:stretch>
+          </a:blipFill>
           <a:ln w="12700">
             <a:solidFill>
               <a:srgbClr val="111827"/>
-            </a:solidFill>
-            <a:prstDash val="solid"/>
-          </a:ln>
-        </p:spPr>
-        <p:txBody>
-          <a:bodyPr/>
-          <a:lstStyle/>
-          <a:p>
-            <a:endParaRPr lang="es-NI"/>
-          </a:p>
-        </p:txBody>
-      </p:sp>
-      <p:sp>
-        <p:nvSpPr>
-          <p:cNvPr id="21" name="Shape 19"/>
-          <p:cNvSpPr/>
-          <p:nvPr/>
-        </p:nvSpPr>
-        <p:spPr>
-          <a:xfrm>
-            <a:off x="9528505" y="2089404"/>
-            <a:ext cx="1837030" cy="3044952"/>
-          </a:xfrm>
-          <a:prstGeom prst="rect">
-            <a:avLst/>
-          </a:prstGeom>
-          <a:solidFill>
-            <a:srgbClr val="FFFFFF"/>
-          </a:solidFill>
-          <a:ln w="9525">
-            <a:solidFill>
-              <a:srgbClr val="D7DCE4"/>
-            </a:solidFill>
-            <a:prstDash val="solid"/>
-          </a:ln>
-        </p:spPr>
-        <p:txBody>
-          <a:bodyPr/>
-          <a:lstStyle/>
-          <a:p>
-            <a:endParaRPr lang="es-NI"/>
-          </a:p>
-        </p:txBody>
-      </p:sp>
-      <p:sp>
-        <p:nvSpPr>
-          <p:cNvPr id="22" name="Shape 20"/>
-          <p:cNvSpPr/>
-          <p:nvPr/>
-        </p:nvSpPr>
-        <p:spPr>
-          <a:xfrm>
-            <a:off x="9618116" y="2336292"/>
-            <a:ext cx="1657807" cy="144018"/>
-          </a:xfrm>
-          <a:prstGeom prst="rect">
-            <a:avLst/>
-          </a:prstGeom>
-          <a:solidFill>
-            <a:srgbClr val="69B6E6"/>
-          </a:solidFill>
-          <a:ln w="12700">
-            <a:solidFill>
-              <a:srgbClr val="FFFFFF"/>
-            </a:solidFill>
-            <a:prstDash val="solid"/>
-          </a:ln>
-        </p:spPr>
-        <p:txBody>
-          <a:bodyPr/>
-          <a:lstStyle/>
-          <a:p>
-            <a:endParaRPr lang="es-NI"/>
-          </a:p>
-        </p:txBody>
-      </p:sp>
-      <p:sp>
-        <p:nvSpPr>
-          <p:cNvPr id="23" name="Shape 21"/>
-          <p:cNvSpPr/>
-          <p:nvPr/>
-        </p:nvSpPr>
-        <p:spPr>
-          <a:xfrm>
-            <a:off x="9618116" y="2974086"/>
-            <a:ext cx="1366571" cy="144018"/>
-          </a:xfrm>
-          <a:prstGeom prst="rect">
-            <a:avLst/>
-          </a:prstGeom>
-          <a:solidFill>
-            <a:srgbClr val="DCE3EC"/>
-          </a:solidFill>
-          <a:ln w="12700">
-            <a:solidFill>
-              <a:srgbClr val="FFFFFF"/>
-            </a:solidFill>
-            <a:prstDash val="solid"/>
-          </a:ln>
-        </p:spPr>
-        <p:txBody>
-          <a:bodyPr/>
-          <a:lstStyle/>
-          <a:p>
-            <a:endParaRPr lang="es-NI"/>
-          </a:p>
-        </p:txBody>
-      </p:sp>
-      <p:sp>
-        <p:nvSpPr>
-          <p:cNvPr id="24" name="Shape 22"/>
-          <p:cNvSpPr/>
-          <p:nvPr/>
-        </p:nvSpPr>
-        <p:spPr>
-          <a:xfrm>
-            <a:off x="9618116" y="3611880"/>
-            <a:ext cx="1075334" cy="144018"/>
-          </a:xfrm>
-          <a:prstGeom prst="rect">
-            <a:avLst/>
-          </a:prstGeom>
-          <a:solidFill>
-            <a:srgbClr val="DCE3EC"/>
-          </a:solidFill>
-          <a:ln w="12700">
-            <a:solidFill>
-              <a:srgbClr val="FFFFFF"/>
-            </a:solidFill>
-            <a:prstDash val="solid"/>
-          </a:ln>
-        </p:spPr>
-        <p:txBody>
-          <a:bodyPr/>
-          <a:lstStyle/>
-          <a:p>
-            <a:endParaRPr lang="es-NI"/>
-          </a:p>
-        </p:txBody>
-      </p:sp>
-      <p:sp>
-        <p:nvSpPr>
-          <p:cNvPr id="25" name="Shape 23"/>
-          <p:cNvSpPr/>
-          <p:nvPr/>
-        </p:nvSpPr>
-        <p:spPr>
-          <a:xfrm>
-            <a:off x="9618116" y="4352544"/>
-            <a:ext cx="370332" cy="370332"/>
-          </a:xfrm>
-          <a:prstGeom prst="ellipse">
-            <a:avLst/>
-          </a:prstGeom>
-          <a:solidFill>
-            <a:srgbClr val="F3961C"/>
-          </a:solidFill>
-          <a:ln w="12700">
-            <a:solidFill>
-              <a:srgbClr val="FFFFFF"/>
             </a:solidFill>
             <a:prstDash val="solid"/>
           </a:ln>

</xml_diff>